<commit_message>
Honest evaluation: hard-case + held-out stress sets vs keyword baseline; pin call language from audio; loss-report floor; tighter loss lexicon; README/deck report measured limits
</commit_message>
<xml_diff>
--- a/docs/AwaazAlert-VecnaVerse.pptx
+++ b/docs/AwaazAlert-VecnaVerse.pptx
@@ -682,7 +682,7 @@
           <a:p>
             <a:r>
               <a:rPr lang="en-US" dirty="0"/>
-              <a:t>Be upfront: the numbers prove real-time + script separation. Emotion accuracy is unproven on Hindi — say so before the judges do.</a:t>
+              <a:t>Be upfront: the numbers prove real-time + script separation. Emotion accuracy is unproven on Hindi, and on a held-out stress set a keyword alarm out-recalled the fused score (5/5 vs 2/5) while raising more false alerts. Say so before the judges do; README has the full table.</a:t>
             </a:r>
             <a:endParaRPr lang="en-US" dirty="0"/>
           </a:p>
@@ -3804,7 +3804,7 @@
                           <a:ea typeface="Calibri" pitchFamily="34" charset="-122"/>
                           <a:cs typeface="Calibri" pitchFamily="34" charset="-120"/>
                         </a:rPr>
-                        <a:t>0.75 s</a:t>
+                        <a:t>0.76 s</a:t>
                       </a:r>
                       <a:endParaRPr lang="en-US" sz="1150" dirty="0">
                         <a:latin typeface="Calibri" charset="0"/>
@@ -3942,7 +3942,7 @@
                           <a:ea typeface="Calibri" pitchFamily="34" charset="-122"/>
                           <a:cs typeface="Calibri" pitchFamily="34" charset="-120"/>
                         </a:rPr>
-                        <a:t>65</a:t>
+                        <a:t>67</a:t>
                       </a:r>
                       <a:endParaRPr lang="en-US" sz="1150" dirty="0">
                         <a:latin typeface="Calibri" charset="0"/>
@@ -4146,7 +4146,7 @@
                           <a:ea typeface="Calibri" pitchFamily="34" charset="-122"/>
                           <a:cs typeface="Calibri" pitchFamily="34" charset="-120"/>
                         </a:rPr>
-                        <a:t>0.52 s</a:t>
+                        <a:t>0.57 s</a:t>
                       </a:r>
                       <a:endParaRPr lang="en-US" sz="1150" dirty="0">
                         <a:latin typeface="Calibri" charset="0"/>
@@ -4488,7 +4488,7 @@
                           <a:ea typeface="Calibri" pitchFamily="34" charset="-122"/>
                           <a:cs typeface="Calibri" pitchFamily="34" charset="-120"/>
                         </a:rPr>
-                        <a:t>0.51 s</a:t>
+                        <a:t>0.52 s</a:t>
                       </a:r>
                       <a:endParaRPr lang="en-US" sz="1150" dirty="0">
                         <a:latin typeface="Calibri" charset="0"/>
@@ -4830,7 +4830,7 @@
                           <a:ea typeface="Calibri" pitchFamily="34" charset="-122"/>
                           <a:cs typeface="Calibri" pitchFamily="34" charset="-120"/>
                         </a:rPr>
-                        <a:t>0.37 s</a:t>
+                        <a:t>0.47 s</a:t>
                       </a:r>
                       <a:endParaRPr lang="en-US" sz="1150" dirty="0">
                         <a:latin typeface="Calibri" charset="0"/>
@@ -5172,7 +5172,7 @@
                           <a:ea typeface="Calibri" pitchFamily="34" charset="-122"/>
                           <a:cs typeface="Calibri" pitchFamily="34" charset="-120"/>
                         </a:rPr>
-                        <a:t>0.50 s</a:t>
+                        <a:t>0.57 s</a:t>
                       </a:r>
                       <a:endParaRPr lang="en-US" sz="1150" dirty="0">
                         <a:latin typeface="Calibri" charset="0"/>
@@ -5261,7 +5261,7 @@
                 <a:ea typeface="Courier New" pitchFamily="34" charset="-122"/>
                 <a:cs typeface="Courier New" pitchFamily="34" charset="-120"/>
               </a:rPr>
-              <a:t>control lowest: PASS · real-time factor 0.13–0.25 on one RTX 4060 laptop GPU</a:t>
+              <a:t>control lowest: PASS · real-time factor 0.16–0.26 on one RTX 4060 laptop GPU</a:t>
             </a:r>
             <a:endParaRPr lang="en-US" sz="1000" dirty="0"/>
           </a:p>
@@ -5300,7 +5300,7 @@
                 <a:ea typeface="Courier New" pitchFamily="34" charset="-122"/>
                 <a:cs typeface="Courier New" pitchFamily="34" charset="-120"/>
               </a:rPr>
-              <a:t>4×</a:t>
+              <a:t>3–4×</a:t>
             </a:r>
             <a:endParaRPr lang="en-US" sz="3400" dirty="0"/>
           </a:p>
@@ -5594,7 +5594,7 @@
               <a:buChar char="—"/>
             </a:pPr>
             <a:r>
-              <a:rPr lang="en-US" sz="1150" dirty="0">
+              <a:rPr lang="en-US" sz="1050" dirty="0">
                 <a:solidFill>
                   <a:srgbClr val="2A2419"/>
                 </a:solidFill>
@@ -5602,9 +5602,9 @@
                 <a:ea typeface="Calibri" pitchFamily="34" charset="-122"/>
                 <a:cs typeface="Calibri" pitchFamily="34" charset="-120"/>
               </a:rPr>
-              <a:t>Demo calls are synthetic: flat affect, distress 0.0–0.11 on every clip. They prove the pipeline and the script path, not emotion accuracy.</a:t>
-            </a:r>
-            <a:endParaRPr lang="en-US" sz="1150" dirty="0"/>
+              <a:t>Demo calls are synthetic (flat affect): they prove the pipeline and script path, not emotion accuracy. Real-call accuracy is unmeasured.</a:t>
+            </a:r>
+            <a:endParaRPr lang="en-US" sz="1050" dirty="0"/>
           </a:p>
           <a:p>
             <a:pPr marL="342900" indent="-342900">
@@ -5615,7 +5615,7 @@
               <a:buChar char="—"/>
             </a:pPr>
             <a:r>
-              <a:rPr lang="en-US" sz="1150" dirty="0">
+              <a:rPr lang="en-US" sz="1050" dirty="0">
                 <a:solidFill>
                   <a:srgbClr val="2A2419"/>
                 </a:solidFill>
@@ -5623,9 +5623,9 @@
                 <a:ea typeface="Calibri" pitchFamily="34" charset="-122"/>
                 <a:cs typeface="Calibri" pitchFamily="34" charset="-120"/>
               </a:rPr>
-              <a:t>No public Hindi SER benchmark exists; the voice branch needs consented real recordings before any accuracy claim.</a:t>
-            </a:r>
-            <a:endParaRPr lang="en-US" sz="1150" dirty="0"/>
+              <a:t>Stress test, 20 extra synthetic calls: on 5 unseen scams a plain keyword alarm caught 5, our fused score 2 — but it raised fewer false alerts (1/4 vs 2/4). Legit and scam calls share vocabulary.</a:t>
+            </a:r>
+            <a:endParaRPr lang="en-US" sz="1050" dirty="0"/>
           </a:p>
           <a:p>
             <a:pPr marL="342900" indent="-342900">
@@ -5636,7 +5636,7 @@
               <a:buChar char="—"/>
             </a:pPr>
             <a:r>
-              <a:rPr lang="en-US" sz="1150" dirty="0">
+              <a:rPr lang="en-US" sz="1050" dirty="0">
                 <a:solidFill>
                   <a:srgbClr val="2A2419"/>
                 </a:solidFill>
@@ -5644,9 +5644,9 @@
                 <a:ea typeface="Calibri" pitchFamily="34" charset="-122"/>
                 <a:cs typeface="Calibri" pitchFamily="34" charset="-120"/>
               </a:rPr>
-              <a:t>One speaker per stream — no diarisation yet.</a:t>
-            </a:r>
-            <a:endParaRPr lang="en-US" sz="1150" dirty="0"/>
+              <a:t>So AwaazAlert is a ranking aid for a human operator, not a scam detector. Next step: consented, expert-labelled calls.</a:t>
+            </a:r>
+            <a:endParaRPr lang="en-US" sz="1050" dirty="0"/>
           </a:p>
           <a:p>
             <a:pPr marL="342900" indent="-342900">
@@ -5657,7 +5657,7 @@
               <a:buChar char="—"/>
             </a:pPr>
             <a:r>
-              <a:rPr lang="en-US" sz="1150" dirty="0">
+              <a:rPr lang="en-US" sz="1050" dirty="0">
                 <a:solidFill>
                   <a:srgbClr val="2A2419"/>
                 </a:solidFill>
@@ -5665,9 +5665,9 @@
                 <a:ea typeface="Calibri" pitchFamily="34" charset="-122"/>
                 <a:cs typeface="Calibri" pitchFamily="34" charset="-120"/>
               </a:rPr>
-              <a:t>Whisper still mishears some Hinglish; the lexicon carries ASR variants.</a:t>
-            </a:r>
-            <a:endParaRPr lang="en-US" sz="1150" dirty="0"/>
+              <a:t>One speaker per stream; Whisper mishears some Hinglish.</a:t>
+            </a:r>
+            <a:endParaRPr lang="en-US" sz="1050" dirty="0"/>
           </a:p>
         </p:txBody>
       </p:sp>

</xml_diff>